<commit_message>
chore(data): refresh weekly/monthly data and IBD split run outputs
</commit_message>
<xml_diff>
--- a/output/skyrizi_ibd_split/deck.pptx
+++ b/output/skyrizi_ibd_split/deck.pptx
@@ -142,9 +142,9 @@
           </c:marker>
           <c:cat>
             <c:strRef>
-              <c:f>Sheet1!$A$2:$A$107</c:f>
+              <c:f>Sheet1!$A$2:$A$111</c:f>
               <c:strCache>
-                <c:ptCount val="106"/>
+                <c:ptCount val="110"/>
                 <c:pt idx="0">
                   <c:v>05-03</c:v>
                 </c:pt>
@@ -462,16 +462,28 @@
                 </c:pt>
                 <c:pt idx="105">
                   <c:v>05-08</c:v>
+                </c:pt>
+                <c:pt idx="106">
+                  <c:v>05-15</c:v>
+                </c:pt>
+                <c:pt idx="107">
+                  <c:v>05-22</c:v>
+                </c:pt>
+                <c:pt idx="108">
+                  <c:v>05-29</c:v>
+                </c:pt>
+                <c:pt idx="109">
+                  <c:v>06-05</c:v>
                 </c:pt>
               </c:strCache>
             </c:strRef>
           </c:cat>
           <c:val>
             <c:numRef>
-              <c:f>Sheet1!$B$2:$B$107</c:f>
+              <c:f>Sheet1!$B$2:$B$111</c:f>
               <c:numCache>
                 <c:formatCode>General</c:formatCode>
-                <c:ptCount val="106"/>
+                <c:ptCount val="110"/>
                 <c:pt idx="0">
                   <c:v>129.214948</c:v>
                 </c:pt>
@@ -789,6 +801,18 @@
                 </c:pt>
                 <c:pt idx="105">
                   <c:v>3621.582263</c:v>
+                </c:pt>
+                <c:pt idx="106">
+                  <c:v>3694.013908</c:v>
+                </c:pt>
+                <c:pt idx="107">
+                  <c:v>3767.894186</c:v>
+                </c:pt>
+                <c:pt idx="108">
+                  <c:v>3843.25207</c:v>
+                </c:pt>
+                <c:pt idx="109">
+                  <c:v>3920.117111</c:v>
                 </c:pt>
               </c:numCache>
             </c:numRef>
@@ -821,9 +845,9 @@
           </c:marker>
           <c:cat>
             <c:strRef>
-              <c:f>Sheet1!$A$2:$A$107</c:f>
+              <c:f>Sheet1!$A$2:$A$111</c:f>
               <c:strCache>
-                <c:ptCount val="106"/>
+                <c:ptCount val="110"/>
                 <c:pt idx="0">
                   <c:v>05-03</c:v>
                 </c:pt>
@@ -1141,16 +1165,28 @@
                 </c:pt>
                 <c:pt idx="105">
                   <c:v>05-08</c:v>
+                </c:pt>
+                <c:pt idx="106">
+                  <c:v>05-15</c:v>
+                </c:pt>
+                <c:pt idx="107">
+                  <c:v>05-22</c:v>
+                </c:pt>
+                <c:pt idx="108">
+                  <c:v>05-29</c:v>
+                </c:pt>
+                <c:pt idx="109">
+                  <c:v>06-05</c:v>
                 </c:pt>
               </c:strCache>
             </c:strRef>
           </c:cat>
           <c:val>
             <c:numRef>
-              <c:f>Sheet1!$C$2:$C$107</c:f>
+              <c:f>Sheet1!$C$2:$C$111</c:f>
               <c:numCache>
                 <c:formatCode>General</c:formatCode>
-                <c:ptCount val="106"/>
+                <c:ptCount val="110"/>
                 <c:pt idx="0">
                   <c:v>3526.895728</c:v>
                 </c:pt>
@@ -1468,6 +1504,18 @@
                 </c:pt>
                 <c:pt idx="105">
                   <c:v>12034.60115</c:v>
+                </c:pt>
+                <c:pt idx="106">
+                  <c:v>12275.293174</c:v>
+                </c:pt>
+                <c:pt idx="107">
+                  <c:v>12520.799037</c:v>
+                </c:pt>
+                <c:pt idx="108">
+                  <c:v>12771.215017</c:v>
+                </c:pt>
+                <c:pt idx="109">
+                  <c:v>13026.639318</c:v>
                 </c:pt>
               </c:numCache>
             </c:numRef>
@@ -1516,8 +1564,8 @@
         <c:lblAlgn val="ctr"/>
         <c:lblOffset val="100"/>
         <c:noMultiLvlLbl val="0"/>
-        <c:tickLblSkip val="11"/>
-        <c:tickMarkSkip val="11"/>
+        <c:tickLblSkip val="12"/>
+        <c:tickMarkSkip val="12"/>
       </c:catAx>
       <c:valAx>
         <c:axId val="2140495176"/>
@@ -4809,7 +4857,7 @@
                 </a:solidFill>
                 <a:latin typeface="Roboto"/>
               </a:rPr>
-              <a:t>Skyrizi's weekly IBD volume has scaled from ~3,656 to ~15,656 TRx since May 2024. Crohn's has led in every week; ulcerative colitis has grown from ~4% to ~23% of the mix since its 2024 launch.</a:t>
+              <a:t>Skyrizi's weekly IBD volume has scaled from ~3,656 to ~16,947 TRx since May 2024. Crohn's has led in every week; ulcerative colitis has grown from ~4% to ~23% of the mix since its 2024 launch.</a:t>
             </a:r>
           </a:p>
         </p:txBody>
@@ -4983,7 +5031,7 @@
                 </a:solidFill>
                 <a:latin typeface="Roboto"/>
               </a:rPr>
-              <a:t>CD ~12,035 vs UC ~3,622 TRx in the latest week (05-08) — about a 77/23 CD/UC split.</a:t>
+              <a:t>CD ~13,027 vs UC ~3,920 TRx in the latest week (06-05) — about a 77/23 CD/UC split.</a:t>
             </a:r>
           </a:p>
         </p:txBody>
@@ -5178,7 +5226,7 @@
                 </a:solidFill>
                 <a:latin typeface="Montserrat Medium"/>
               </a:rPr>
-              <a:t>~4x ramp</a:t>
+              <a:t>~5x ramp</a:t>
             </a:r>
           </a:p>
         </p:txBody>
@@ -5217,7 +5265,7 @@
                 </a:solidFill>
                 <a:latin typeface="Roboto"/>
               </a:rPr>
-              <a:t>Skyrizi's IBD volume rose from ~3,656 to ~15,656 weekly TRx (OBI maintenance is ~99.9% of it).</a:t>
+              <a:t>Skyrizi's IBD volume rose from ~3,656 to ~16,947 weekly TRx (OBI maintenance is ~99.9% of it).</a:t>
             </a:r>
           </a:p>
         </p:txBody>

</xml_diff>